<commit_message>
docs: align final submission decks strictly with official Health-a-thon 2026 template requirements
</commit_message>
<xml_diff>
--- a/Health-a-thon 2026 - Final Presentation (Binary Minds).pptx
+++ b/Health-a-thon 2026 - Final Presentation (Binary Minds).pptx
@@ -18310,7 +18310,7 @@
         <p:spPr>
           <a:xfrm>
             <a:off x="1371600" y="3886200"/>
-            <a:ext cx="9418320" cy="258532"/>
+            <a:ext cx="9418320" cy="731520"/>
           </a:xfrm>
           <a:prstGeom prst="rect">
             <a:avLst/>
@@ -18326,35 +18326,30 @@
           </a:bodyPr>
           <a:lstStyle/>
           <a:p>
-            <a:pPr indent="0" lvl="0" marL="0" marR="0" rtl="0" algn="ctr">
-              <a:lnSpc>
-                <a:spcPct val="100000"/>
-              </a:lnSpc>
-              <a:spcBef>
-                <a:spcPts val="0"/>
-              </a:spcBef>
-              <a:spcAft>
-                <a:spcPts val="300"/>
-              </a:spcAft>
-              <a:buClr>
-                <a:srgbClr val="000000"/>
-              </a:buClr>
-              <a:buSzPts val="1200"/>
-              <a:buFont typeface="Arial"/>
-              <a:buNone/>
+            <a:pPr algn="ctr">
+              <a:defRPr sz="1300">
+                <a:solidFill>
+                  <a:srgbClr val="0F172A"/>
+                </a:solidFill>
+                <a:latin typeface="Calibri"/>
+              </a:defRPr>
             </a:pPr>
             <a:r>
-              <a:t>saisanthosh05012006@gmail.com  |  https://rounds-ai-umber.vercel.app/</a:t>
+              <a:t>saisanthosh05012006@gmail.com   |   https://rounds-ai-umber.vercel.app/</a:t>
             </a:r>
-            <a:endParaRPr b="0" i="0" spc="0" sz="1400" u="none" cap="none" strike="noStrike">
-              <a:solidFill>
-                <a:srgbClr val="000000"/>
-              </a:solidFill>
-              <a:latin typeface="Arial"/>
-              <a:ea typeface="Arial"/>
-              <a:cs typeface="Arial"/>
-              <a:sym typeface="Arial"/>
-            </a:endParaRPr>
+          </a:p>
+          <a:p>
+            <a:pPr algn="ctr">
+              <a:defRPr sz="1300">
+                <a:solidFill>
+                  <a:srgbClr val="0F172A"/>
+                </a:solidFill>
+                <a:latin typeface="Calibri"/>
+              </a:defRPr>
+            </a:pPr>
+            <a:r>
+              <a:t>Demo Video: [Insert 2–3 Minute Demo Video URL]   |   GitHub: https://github.com/santhoshh005/Rounds_AI</a:t>
+            </a:r>
           </a:p>
         </p:txBody>
       </p:sp>
@@ -18505,44 +18500,7 @@
             <a:spAutoFit/>
           </a:bodyPr>
           <a:lstStyle/>
-          <a:p>
-            <a:pPr algn="ctr">
-              <a:spcBef>
-                <a:spcPts val="0"/>
-              </a:spcBef>
-              <a:spcAft>
-                <a:spcPts val="300"/>
-              </a:spcAft>
-            </a:pPr>
-            <a:r>
-              <a:rPr sz="1000" b="0" i="0">
-                <a:solidFill>
-                  <a:srgbClr val="1A4599"/>
-                </a:solidFill>
-                <a:latin typeface="Aptos"/>
-              </a:rPr>
-              <a:t>GitHub: https://github.com/santhoshh005/Rounds_AI</a:t>
-            </a:r>
-          </a:p>
-          <a:p>
-            <a:pPr algn="ctr">
-              <a:spcBef>
-                <a:spcPts val="0"/>
-              </a:spcBef>
-              <a:spcAft>
-                <a:spcPts val="300"/>
-              </a:spcAft>
-            </a:pPr>
-            <a:r>
-              <a:rPr sz="1000" b="0" i="0">
-                <a:solidFill>
-                  <a:srgbClr val="1A4599"/>
-                </a:solidFill>
-                <a:latin typeface="Aptos"/>
-              </a:rPr>
-              <a:t>Demo video: [Insert 2–3 Minute Demo Video URL]</a:t>
-            </a:r>
-          </a:p>
+          <a:p/>
         </p:txBody>
       </p:sp>
     </p:spTree>

</xml_diff>

<commit_message>
docs: add official team members, clinical lead Dr. Amrut S Kadam (BMCRI), and track details
</commit_message>
<xml_diff>
--- a/Health-a-thon 2026 - Final Presentation (Binary Minds).pptx
+++ b/Health-a-thon 2026 - Final Presentation (Binary Minds).pptx
@@ -15855,41 +15855,9 @@
           </a:bodyPr>
           <a:lstStyle/>
           <a:p>
-            <a:pPr indent="0" lvl="0" marL="0" marR="0" rtl="0" algn="ctr">
-              <a:lnSpc>
-                <a:spcPct val="100000"/>
-              </a:lnSpc>
-              <a:spcBef>
-                <a:spcPts val="0"/>
-              </a:spcBef>
-              <a:spcAft>
-                <a:spcPts val="300"/>
-              </a:spcAft>
-              <a:buClr>
-                <a:srgbClr val="000000"/>
-              </a:buClr>
-              <a:buSzPts val="1200"/>
-              <a:buFont typeface="Arial"/>
-              <a:buNone/>
-            </a:pPr>
             <a:r>
-              <a:rPr sz="1100" b="1" i="0">
-                <a:solidFill>
-                  <a:srgbClr val="1A4599"/>
-                </a:solidFill>
-                <a:latin typeface="Aptos"/>
-              </a:rPr>
-              <a:t>TEAM CODE  [Insert Team Code]</a:t>
+              <a:t>TEAM CODE  1RKUPH</a:t>
             </a:r>
-            <a:endParaRPr b="0" i="0" spc="0" sz="1400" u="none" cap="none" strike="noStrike">
-              <a:solidFill>
-                <a:srgbClr val="000000"/>
-              </a:solidFill>
-              <a:latin typeface="Arial"/>
-              <a:ea typeface="Arial"/>
-              <a:cs typeface="Arial"/>
-              <a:sym typeface="Arial"/>
-            </a:endParaRPr>
           </a:p>
         </p:txBody>
       </p:sp>
@@ -18263,41 +18231,17 @@
           </a:bodyPr>
           <a:lstStyle/>
           <a:p>
-            <a:pPr indent="0" lvl="0" marL="0" marR="0" rtl="0" algn="ctr">
-              <a:lnSpc>
-                <a:spcPct val="100000"/>
-              </a:lnSpc>
-              <a:spcBef>
-                <a:spcPts val="0"/>
-              </a:spcBef>
-              <a:spcAft>
-                <a:spcPts val="300"/>
-              </a:spcAft>
-              <a:buClr>
-                <a:srgbClr val="000000"/>
-              </a:buClr>
-              <a:buSzPts val="1600"/>
-              <a:buFont typeface="Arial"/>
-              <a:buNone/>
+            <a:pPr>
+              <a:defRPr sz="1500" b="1">
+                <a:solidFill>
+                  <a:srgbClr val="0F172A"/>
+                </a:solidFill>
+                <a:latin typeface="Calibri"/>
+              </a:defRPr>
             </a:pPr>
             <a:r>
-              <a:rPr sz="1300" b="1" i="0">
-                <a:solidFill>
-                  <a:srgbClr val="00843D"/>
-                </a:solidFill>
-                <a:latin typeface="Aptos"/>
-              </a:rPr>
-              <a:t>Binary Minds  •  [Insert Team Code]</a:t>
+              <a:t>Binary Minds  •  Team Code: 1RKUPH</a:t>
             </a:r>
-            <a:endParaRPr b="0" i="0" spc="0" sz="1400" u="none" cap="none" strike="noStrike">
-              <a:solidFill>
-                <a:srgbClr val="000000"/>
-              </a:solidFill>
-              <a:latin typeface="Arial"/>
-              <a:ea typeface="Arial"/>
-              <a:cs typeface="Arial"/>
-              <a:sym typeface="Arial"/>
-            </a:endParaRPr>
           </a:p>
         </p:txBody>
       </p:sp>
@@ -18327,9 +18271,22 @@
           <a:lstStyle/>
           <a:p>
             <a:pPr algn="ctr">
-              <a:defRPr sz="1300">
-                <a:solidFill>
-                  <a:srgbClr val="0F172A"/>
+              <a:defRPr sz="1200" b="1">
+                <a:solidFill>
+                  <a:srgbClr val="1E293B"/>
+                </a:solidFill>
+                <a:latin typeface="Calibri"/>
+              </a:defRPr>
+            </a:pPr>
+            <a:r>
+              <a:t>Chalicheemala Surya Thejas (Team Leader)  •  Gaddam Sai Santhosh  •  Dr. Amrut S Kadam (BMCRI)</a:t>
+            </a:r>
+          </a:p>
+          <a:p>
+            <a:pPr algn="ctr">
+              <a:defRPr sz="1200">
+                <a:solidFill>
+                  <a:srgbClr val="334155"/>
                 </a:solidFill>
                 <a:latin typeface="Calibri"/>
               </a:defRPr>
@@ -18340,15 +18297,15 @@
           </a:p>
           <a:p>
             <a:pPr algn="ctr">
-              <a:defRPr sz="1300">
-                <a:solidFill>
-                  <a:srgbClr val="0F172A"/>
+              <a:defRPr sz="1200">
+                <a:solidFill>
+                  <a:srgbClr val="334155"/>
                 </a:solidFill>
                 <a:latin typeface="Calibri"/>
               </a:defRPr>
             </a:pPr>
             <a:r>
-              <a:t>Demo Video: [Insert 2–3 Minute Demo Video URL]   |   GitHub: https://github.com/santhoshh005/Rounds_AI</a:t>
+              <a:t>Demo Video: https://youtu.be/Kia1C-a0QLk   |   GitHub: https://github.com/santhoshh005/Rounds_AI</a:t>
             </a:r>
           </a:p>
         </p:txBody>
@@ -18840,22 +18797,16 @@
           </a:bodyPr>
           <a:lstStyle/>
           <a:p>
-            <a:pPr algn="l">
-              <a:spcBef>
-                <a:spcPts val="0"/>
-              </a:spcBef>
-              <a:spcAft>
-                <a:spcPts val="300"/>
-              </a:spcAft>
+            <a:pPr>
+              <a:defRPr sz="1300" b="1">
+                <a:solidFill>
+                  <a:srgbClr val="0F172A"/>
+                </a:solidFill>
+                <a:latin typeface="Calibri"/>
+              </a:defRPr>
             </a:pPr>
             <a:r>
-              <a:rPr sz="1400" b="1" i="0">
-                <a:solidFill>
-                  <a:srgbClr val="0F172A"/>
-                </a:solidFill>
-                <a:latin typeface="Aptos"/>
-              </a:rPr>
-              <a:t>TEAM LEAD  |  Gaddam Sai Santhosh</a:t>
+              <a:t>ENGINEERING TEAM  |  Binary Minds</a:t>
             </a:r>
           </a:p>
         </p:txBody>
@@ -18883,50 +18834,28 @@
           <a:lstStyle/>
           <a:p>
             <a:pPr>
-              <a:spcAft>
-                <a:spcPts val="400"/>
-              </a:spcAft>
+              <a:defRPr sz="1050">
+                <a:solidFill>
+                  <a:srgbClr val="334155"/>
+                </a:solidFill>
+                <a:latin typeface="Calibri"/>
+              </a:defRPr>
             </a:pPr>
             <a:r>
-              <a:rPr sz="1140">
+              <a:t>•  Chalicheemala Surya Thejas — Team Leader &amp; Technical Lead (Full-stack architecture &amp; systems deployment).</a:t>
+            </a:r>
+          </a:p>
+          <a:p>
+            <a:pPr>
+              <a:defRPr sz="1050">
                 <a:solidFill>
                   <a:srgbClr val="334155"/>
                 </a:solidFill>
-                <a:latin typeface="Aptos"/>
-              </a:rPr>
-              <a:t>•  Full-Stack AI Systems Engineer</a:t>
-            </a:r>
-          </a:p>
-          <a:p>
-            <a:pPr>
-              <a:spcAft>
-                <a:spcPts val="400"/>
-              </a:spcAft>
+                <a:latin typeface="Calibri"/>
+              </a:defRPr>
             </a:pPr>
             <a:r>
-              <a:rPr sz="1140">
-                <a:solidFill>
-                  <a:srgbClr val="334155"/>
-                </a:solidFill>
-                <a:latin typeface="Aptos"/>
-              </a:rPr>
-              <a:t>•  Architected the local Whisper voice pipeline and multimodal lab OCR.</a:t>
-            </a:r>
-          </a:p>
-          <a:p>
-            <a:pPr>
-              <a:spcAft>
-                <a:spcPts val="400"/>
-              </a:spcAft>
-            </a:pPr>
-            <a:r>
-              <a:rPr sz="1140">
-                <a:solidFill>
-                  <a:srgbClr val="334155"/>
-                </a:solidFill>
-                <a:latin typeface="Aptos"/>
-              </a:rPr>
-              <a:t>•  Built CTCAE v5.0 grading, real-time SSE sync, and the Next.js 15 workstation.</a:t>
+              <a:t>•  Gaddam Sai Santhosh — Full-Stack AI Systems Engineer (Local Whisper voice pipeline, Gemini lab OCR, CTCAE v5.0 engine, SSE live sync &amp; Next.js 15 workstation).</a:t>
             </a:r>
           </a:p>
         </p:txBody>
@@ -19041,22 +18970,16 @@
           </a:bodyPr>
           <a:lstStyle/>
           <a:p>
-            <a:pPr algn="l">
-              <a:spcBef>
-                <a:spcPts val="0"/>
-              </a:spcBef>
-              <a:spcAft>
-                <a:spcPts val="300"/>
-              </a:spcAft>
+            <a:pPr>
+              <a:defRPr sz="1300" b="1">
+                <a:solidFill>
+                  <a:srgbClr val="0F172A"/>
+                </a:solidFill>
+                <a:latin typeface="Calibri"/>
+              </a:defRPr>
             </a:pPr>
             <a:r>
-              <a:rPr sz="1400" b="1" i="0">
-                <a:solidFill>
-                  <a:srgbClr val="0F172A"/>
-                </a:solidFill>
-                <a:latin typeface="Aptos"/>
-              </a:rPr>
-              <a:t>DOCTOR PARTNER  |  Consultant Medical Oncologist</a:t>
+              <a:t>DOCTOR PARTNER  |  Dr. Amrut S Kadam</a:t>
             </a:r>
           </a:p>
         </p:txBody>
@@ -19084,50 +19007,41 @@
           <a:lstStyle/>
           <a:p>
             <a:pPr>
-              <a:spcAft>
-                <a:spcPts val="400"/>
-              </a:spcAft>
+              <a:defRPr sz="1050">
+                <a:solidFill>
+                  <a:srgbClr val="334155"/>
+                </a:solidFill>
+                <a:latin typeface="Calibri"/>
+              </a:defRPr>
             </a:pPr>
             <a:r>
-              <a:rPr sz="1120">
+              <a:t>•  Clinical Lead &amp; Inpatient Ward Attending, Victoria Hospital, Bangalore Medical College &amp; Research Institute (BMCRI).</a:t>
+            </a:r>
+          </a:p>
+          <a:p>
+            <a:pPr>
+              <a:defRPr sz="1050">
                 <a:solidFill>
                   <a:srgbClr val="334155"/>
                 </a:solidFill>
-                <a:latin typeface="Aptos"/>
-              </a:rPr>
-              <a:t>•  Inpatient oncology ward attending; co-designed clinical ward workflows.</a:t>
-            </a:r>
-          </a:p>
-          <a:p>
-            <a:pPr>
-              <a:spcAft>
-                <a:spcPts val="400"/>
-              </a:spcAft>
+                <a:latin typeface="Calibri"/>
+              </a:defRPr>
             </a:pPr>
             <a:r>
-              <a:rPr sz="1120">
+              <a:t>•  Co-designed clinical ward workflows, verified CTCAE v5.0 myelosuppression criteria and 120+ drug phonetic normalization rules.</a:t>
+            </a:r>
+          </a:p>
+          <a:p>
+            <a:pPr>
+              <a:defRPr sz="1050">
                 <a:solidFill>
                   <a:srgbClr val="334155"/>
                 </a:solidFill>
-                <a:latin typeface="Aptos"/>
-              </a:rPr>
-              <a:t>•  Reviewed CTCAE v5.0 myelosuppression thresholds and 120+ drug phonetic rules.</a:t>
-            </a:r>
-          </a:p>
-          <a:p>
-            <a:pPr>
-              <a:spcAft>
-                <a:spcPts val="400"/>
-              </a:spcAft>
+                <a:latin typeface="Calibri"/>
+              </a:defRPr>
             </a:pPr>
             <a:r>
-              <a:rPr sz="1120">
-                <a:solidFill>
-                  <a:srgbClr val="334155"/>
-                </a:solidFill>
-                <a:latin typeface="Aptos"/>
-              </a:rPr>
-              <a:t>•  Reviewed febrile-neutropenia screening criteria cited as IDSA/ASCO 2018.</a:t>
+              <a:t>•  Reviewed IDSA/ASCO 2018 febrile-neutropenia screening sentinels and clinical risk boundaries.</a:t>
             </a:r>
           </a:p>
         </p:txBody>
@@ -19242,22 +19156,16 @@
           </a:bodyPr>
           <a:lstStyle/>
           <a:p>
-            <a:pPr algn="l">
-              <a:spcBef>
-                <a:spcPts val="0"/>
-              </a:spcBef>
-              <a:spcAft>
-                <a:spcPts val="300"/>
-              </a:spcAft>
+            <a:pPr>
+              <a:defRPr sz="1200" b="1">
+                <a:solidFill>
+                  <a:srgbClr val="0F172A"/>
+                </a:solidFill>
+                <a:latin typeface="Calibri"/>
+              </a:defRPr>
             </a:pPr>
             <a:r>
-              <a:rPr sz="1300" b="1" i="0">
-                <a:solidFill>
-                  <a:srgbClr val="0F172A"/>
-                </a:solidFill>
-                <a:latin typeface="Aptos"/>
-              </a:rPr>
-              <a:t>ORGANISATION &amp; CLINICAL SETTING</a:t>
+              <a:t>ORGANISATION, CLINICAL SETTING &amp; TRACK</a:t>
             </a:r>
           </a:p>
         </p:txBody>
@@ -19284,22 +19192,29 @@
           </a:bodyPr>
           <a:lstStyle/>
           <a:p>
-            <a:pPr algn="l">
-              <a:spcBef>
-                <a:spcPts val="0"/>
-              </a:spcBef>
-              <a:spcAft>
-                <a:spcPts val="300"/>
-              </a:spcAft>
+            <a:pPr>
+              <a:defRPr sz="1100">
+                <a:solidFill>
+                  <a:srgbClr val="334155"/>
+                </a:solidFill>
+                <a:latin typeface="Calibri"/>
+              </a:defRPr>
             </a:pPr>
             <a:r>
-              <a:rPr sz="1250" b="0" i="0">
+              <a:t>•  Institution: Victoria Hospital, Bangalore Medical College &amp; Research Institute (BMCRI) &amp; Binary Minds.</a:t>
+            </a:r>
+          </a:p>
+          <a:p>
+            <a:pPr>
+              <a:defRPr sz="1100">
                 <a:solidFill>
                   <a:srgbClr val="334155"/>
                 </a:solidFill>
-                <a:latin typeface="Aptos"/>
-              </a:rPr>
-              <a:t>Healthcare Engineering &amp; Oncology Research Collaboration, focused on clinician documentation burden reduction and medication safety in inpatient cancer care.</a:t>
+                <a:latin typeface="Calibri"/>
+              </a:defRPr>
+            </a:pPr>
+            <a:r>
+              <a:t>•  Track: Cancer · Doctor / Care Team · Doctor Productivity &amp; Knowledge Assistant (Health-a-thon 2026).</a:t>
             </a:r>
           </a:p>
         </p:txBody>

</xml_diff>